<commit_message>
feat: bilingual dynamic PPTX presentation download (AR & EN) and 8 feedback report improvements
</commit_message>
<xml_diff>
--- a/report/Eco-Drain_WEFE_Nexus_5Min_Pitch.pptx
+++ b/report/Eco-Drain_WEFE_Nexus_5Min_Pitch.pptx
@@ -3142,7 +3142,7 @@
         <p:spPr>
           <a:xfrm>
             <a:off x="731520" y="365760"/>
-            <a:ext cx="10728655" cy="1005840"/>
+            <a:ext cx="10728655" cy="1051560"/>
           </a:xfrm>
           <a:prstGeom prst="rect">
             <a:avLst/>
@@ -3155,7 +3155,7 @@
           </a:bodyPr>
           <a:lstStyle/>
           <a:p>
-            <a:pPr>
+            <a:pPr algn="r">
               <a:defRPr sz="950" b="1">
                 <a:solidFill>
                   <a:srgbClr val="15B5A4"/>
@@ -3163,23 +3163,23 @@
               </a:defRPr>
             </a:pPr>
             <a:r>
-              <a:t>SLIDE 1 OF 3 | 5-MIN EXECUTIVE PITCH | WEFE NEXUS PROFESSIONAL SERIES</a:t>
-            </a:r>
-          </a:p>
-          <a:p>
-            <a:pPr>
-              <a:defRPr sz="2000" b="1">
+              <a:t>الشريحة 1 من 3 | عرض تنفيذي في 5 دقائق | برنامج تمويل المرونة ومحور WEFE</a:t>
+            </a:r>
+          </a:p>
+          <a:p>
+            <a:pPr algn="r">
+              <a:defRPr sz="1900" b="1">
                 <a:solidFill>
                   <a:srgbClr val="F8FAFC"/>
                 </a:solidFill>
               </a:defRPr>
             </a:pPr>
             <a:r>
-              <a:t>Eco-Drain: Invisible Tamper-Proof Subsurface Drainage Retrofitting</a:t>
-            </a:r>
-          </a:p>
-          <a:p>
-            <a:pPr>
+              <a:t>إيكو-درين (Eco-Drain): إحلال وتجديد شبكات الصرف المغطى الذكية ومقاومة التلاعب</a:t>
+            </a:r>
+          </a:p>
+          <a:p>
+            <a:pPr algn="r">
               <a:defRPr sz="1100">
                 <a:solidFill>
                   <a:srgbClr val="F0C860"/>
@@ -3187,7 +3187,7 @@
               </a:defRPr>
             </a:pPr>
             <a:r>
-              <a:t>1. Project Title &amp; Problem Addressed | 3. Lead Institution &amp; Key Governance Arrangements</a:t>
+              <a:t>1. عنوان المشروع والأزمة الهيدروليكية | 3. الجهة القائدة، الشركاء وهيكل الحوكمة</a:t>
             </a:r>
           </a:p>
         </p:txBody>
@@ -3200,8 +3200,8 @@
         </p:nvSpPr>
         <p:spPr>
           <a:xfrm>
-            <a:off x="731520" y="1463040"/>
-            <a:ext cx="5212080" cy="2377440"/>
+            <a:off x="6217920" y="1463040"/>
+            <a:ext cx="5242255" cy="2377440"/>
           </a:xfrm>
           <a:prstGeom prst="roundRect">
             <a:avLst/>
@@ -3245,8 +3245,8 @@
         </p:nvSpPr>
         <p:spPr>
           <a:xfrm>
-            <a:off x="914400" y="1600200"/>
-            <a:ext cx="4846320" cy="365760"/>
+            <a:off x="6400800" y="1600200"/>
+            <a:ext cx="4876495" cy="365760"/>
           </a:xfrm>
           <a:prstGeom prst="rect">
             <a:avLst/>
@@ -3259,7 +3259,7 @@
           </a:bodyPr>
           <a:lstStyle/>
           <a:p>
-            <a:pPr>
+            <a:pPr algn="r">
               <a:defRPr sz="1200" b="1">
                 <a:solidFill>
                   <a:srgbClr val="EF4444"/>
@@ -3267,7 +3267,7 @@
               </a:defRPr>
             </a:pPr>
             <a:r>
-              <a:t>🚨 1. National Problem Statement &amp; Delta Water Crisis</a:t>
+              <a:t>🚨 1. بيان المشكلة المائية وتدهور الشبكات بالدلتا</a:t>
             </a:r>
           </a:p>
         </p:txBody>
@@ -3280,8 +3280,8 @@
         </p:nvSpPr>
         <p:spPr>
           <a:xfrm>
-            <a:off x="914400" y="1965960"/>
-            <a:ext cx="4846320" cy="1783080"/>
+            <a:off x="6400800" y="1965960"/>
+            <a:ext cx="4876495" cy="1783080"/>
           </a:xfrm>
           <a:prstGeom prst="rect">
             <a:avLst/>
@@ -3294,39 +3294,39 @@
           </a:bodyPr>
           <a:lstStyle/>
           <a:p>
-            <a:pPr>
-              <a:defRPr sz="1000">
+            <a:pPr algn="r">
+              <a:defRPr sz="950">
                 <a:solidFill>
                   <a:srgbClr val="F8FAFC"/>
                 </a:solidFill>
               </a:defRPr>
             </a:pPr>
             <a:r>
-              <a:t>• Severe Water Scarcity: Egypt's quota is 55.5 BCM for 106M+ people -&gt; 560 m³/capita (below 1,000 m³ water poverty line).</a:t>
-            </a:r>
-          </a:p>
-          <a:p>
-            <a:pPr>
-              <a:defRPr sz="1000">
+              <a:t>• الفقر المائي الحرج: حصة مصر الثابتة 55.5 مليار م³ لـ 106+ مليون نسمة تعني نصيب فرد 560 م³/سنة (تحت خط الفقر المائي العالمي 1,000 م³).</a:t>
+            </a:r>
+          </a:p>
+          <a:p>
+            <a:pPr algn="r">
+              <a:defRPr sz="950">
                 <a:solidFill>
                   <a:srgbClr val="F8FAFC"/>
                 </a:solidFill>
               </a:defRPr>
             </a:pPr>
             <a:r>
-              <a:t>• 2.3 Million Feddans Expired: Aging Nile Delta subsurface drainage (&gt;20 yr design life) causes waterlogging &amp; root-zone salinity, slashing crop yields by 10–30%.</a:t>
-            </a:r>
-          </a:p>
-          <a:p>
-            <a:pPr>
-              <a:defRPr sz="1000">
+              <a:t>• 2.3 مليون فدان متقادمة: شبكات الصرف المغطى تجاوزت عمرها التصميمي (20-25 سنة) مسببة تغدق الجذور وتملح التربة وخسارة 10-30% من المحاصيل.</a:t>
+            </a:r>
+          </a:p>
+          <a:p>
+            <a:pPr algn="r">
+              <a:defRPr sz="950">
                 <a:solidFill>
                   <a:srgbClr val="F8FAFC"/>
                 </a:solidFill>
               </a:defRPr>
             </a:pPr>
             <a:r>
-              <a:t>• The Invisible Infrastructure Gap: Buried networks cannot be visually monitored, resulting in silent failures undetected until topsoil salinization is severe.</a:t>
+              <a:t>• أزمة البنية غير المرئية: الشبكات مدفونة تحت الأرض؛ لا يمكن فحصها بصرياً وتتأخر الصيانة لسنوات حتى تظهر أعراض تلف المحصول.</a:t>
             </a:r>
           </a:p>
         </p:txBody>
@@ -3339,8 +3339,8 @@
         </p:nvSpPr>
         <p:spPr>
           <a:xfrm>
-            <a:off x="731520" y="3977639"/>
-            <a:ext cx="5212080" cy="2423160"/>
+            <a:off x="6217920" y="3977639"/>
+            <a:ext cx="5242255" cy="2423160"/>
           </a:xfrm>
           <a:prstGeom prst="roundRect">
             <a:avLst/>
@@ -3384,8 +3384,8 @@
         </p:nvSpPr>
         <p:spPr>
           <a:xfrm>
-            <a:off x="914400" y="4114799"/>
-            <a:ext cx="4846320" cy="365760"/>
+            <a:off x="6400800" y="4114799"/>
+            <a:ext cx="4876495" cy="365760"/>
           </a:xfrm>
           <a:prstGeom prst="rect">
             <a:avLst/>
@@ -3398,7 +3398,7 @@
           </a:bodyPr>
           <a:lstStyle/>
           <a:p>
-            <a:pPr>
+            <a:pPr algn="r">
               <a:defRPr sz="1200" b="1">
                 <a:solidFill>
                   <a:srgbClr val="F0C860"/>
@@ -3406,7 +3406,7 @@
               </a:defRPr>
             </a:pPr>
             <a:r>
-              <a:t>🛡️ 2. The Tampering Challenge &amp; Invisible Solution</a:t>
+              <a:t>🛡️ 2. تحدي التلاعب الزراعي وابتكار الغرف غير المرئية</a:t>
             </a:r>
           </a:p>
         </p:txBody>
@@ -3419,8 +3419,8 @@
         </p:nvSpPr>
         <p:spPr>
           <a:xfrm>
-            <a:off x="914400" y="4480559"/>
-            <a:ext cx="4846320" cy="1828800"/>
+            <a:off x="6400800" y="4480559"/>
+            <a:ext cx="4876495" cy="1828800"/>
           </a:xfrm>
           <a:prstGeom prst="rect">
             <a:avLst/>
@@ -3433,39 +3433,39 @@
           </a:bodyPr>
           <a:lstStyle/>
           <a:p>
-            <a:pPr>
-              <a:defRPr sz="1000">
+            <a:pPr algn="r">
+              <a:defRPr sz="950">
                 <a:solidFill>
                   <a:srgbClr val="F8FAFC"/>
                 </a:solidFill>
               </a:defRPr>
             </a:pPr>
             <a:r>
-              <a:t>• The Vulnerability: EPADP records show 25–40% of drainage failures stem from unauthorized farmer modifications (blocking manholes for rice or extracting drainage).</a:t>
-            </a:r>
-          </a:p>
-          <a:p>
-            <a:pPr>
-              <a:defRPr sz="1000">
+              <a:t>• التعديات الزراعية العشوائية: سجلات هيئة الصرف (EPADP) توثق أن 25-40% من أعطال الصرف ناجمة عن سد المزارعين للمجمعات لحبس المياه للأرز.</a:t>
+            </a:r>
+          </a:p>
+          <a:p>
+            <a:pPr algn="r">
+              <a:defRPr sz="950">
                 <a:solidFill>
                   <a:srgbClr val="F8FAFC"/>
                 </a:solidFill>
               </a:defRPr>
             </a:pPr>
             <a:r>
-              <a:t>• Eco-Drain Core Innovation: Replacing surface manholes with invisible chambers buried 30–50 cm underground, accessible only via RFID tags &amp; GPS.</a:t>
-            </a:r>
-          </a:p>
-          <a:p>
-            <a:pPr>
-              <a:defRPr sz="1000">
+              <a:t>• ابتكار الغرف الغاطسة: استبدال الغرف السطحية بغرف مدفونة 30-50 سم تحت الأرض مع شرائح RFID ومواقع GPS للصيانة الرسمية فقط.</a:t>
+            </a:r>
+          </a:p>
+          <a:p>
+            <a:pPr algn="r">
+              <a:defRPr sz="950">
                 <a:solidFill>
                   <a:srgbClr val="F8FAFC"/>
                 </a:solidFill>
               </a:defRPr>
             </a:pPr>
             <a:r>
-              <a:t>• Active Deterrence: Accelerometers detect digging (&gt;2.5g), triggering instant AES-128 GPS alerts via NB-IoT to control centers, stopping sabotage immediately.</a:t>
+              <a:t>• إنذار لحظي مشفر: حساسات MPU6050 ترصد أي اهتزاز أو حفر (&gt;2.5g) وتبث إنذار طوارئ GPS مشفر بـ AES-128 عبر NB-IoT إلى مركز التحكم.</a:t>
             </a:r>
           </a:p>
         </p:txBody>
@@ -3478,8 +3478,8 @@
         </p:nvSpPr>
         <p:spPr>
           <a:xfrm>
-            <a:off x="6217920" y="1463040"/>
-            <a:ext cx="5242255" cy="4937760"/>
+            <a:off x="731520" y="1463040"/>
+            <a:ext cx="5212080" cy="4937760"/>
           </a:xfrm>
           <a:prstGeom prst="roundRect">
             <a:avLst/>
@@ -3523,8 +3523,8 @@
         </p:nvSpPr>
         <p:spPr>
           <a:xfrm>
-            <a:off x="6400800" y="1600200"/>
-            <a:ext cx="4876495" cy="365760"/>
+            <a:off x="914400" y="1600200"/>
+            <a:ext cx="4846320" cy="365760"/>
           </a:xfrm>
           <a:prstGeom prst="rect">
             <a:avLst/>
@@ -3537,7 +3537,7 @@
           </a:bodyPr>
           <a:lstStyle/>
           <a:p>
-            <a:pPr>
+            <a:pPr algn="r">
               <a:defRPr sz="1200" b="1">
                 <a:solidFill>
                   <a:srgbClr val="15B5A4"/>
@@ -3545,7 +3545,7 @@
               </a:defRPr>
             </a:pPr>
             <a:r>
-              <a:t>🏛️ 3. Lead Institution, Key Partners &amp; Governance Structure</a:t>
+              <a:t>🏛️ 3. الجهة القائدة، الشركاء وهيكل الحوكمة المؤسسية</a:t>
             </a:r>
           </a:p>
         </p:txBody>
@@ -3558,8 +3558,8 @@
         </p:nvSpPr>
         <p:spPr>
           <a:xfrm>
-            <a:off x="6400800" y="1965960"/>
-            <a:ext cx="4876495" cy="4343400"/>
+            <a:off x="914400" y="1965960"/>
+            <a:ext cx="4846320" cy="4343400"/>
           </a:xfrm>
           <a:prstGeom prst="rect">
             <a:avLst/>
@@ -3572,95 +3572,83 @@
           </a:bodyPr>
           <a:lstStyle/>
           <a:p>
-            <a:pPr>
-              <a:defRPr sz="1050" b="1">
+            <a:pPr algn="r">
+              <a:defRPr sz="1000" b="1">
                 <a:solidFill>
                   <a:srgbClr val="F0C860"/>
                 </a:solidFill>
               </a:defRPr>
             </a:pPr>
             <a:r>
-              <a:t>• Lead Executive Institution: Ministry of Water Resources and Irrigation (MWRI) / Egyptian Public Authority for Drainage Projects (EPADP - Technical Office Lower Egypt).</a:t>
-            </a:r>
-          </a:p>
-          <a:p>
-            <a:pPr>
-              <a:defRPr sz="950">
+              <a:t>• الجهة القائدة التنفيذية: وزارة الموارد المائية والري (MWRI) / الهيئة العامة لمشروعات الصرف (EPADP - المكتب الفني للوجه البحري).</a:t>
+            </a:r>
+          </a:p>
+          <a:p>
+            <a:pPr algn="r">
+              <a:defRPr sz="900">
                 <a:solidFill>
                   <a:srgbClr val="F8FAFC"/>
                 </a:solidFill>
               </a:defRPr>
             </a:pPr>
             <a:r>
-              <a:t>• Key Technical Partners: Drainage Research Institute (DRI - NWRC) for soil telemetry, hydraulic criteria &amp; independent MRV verification.</a:t>
-            </a:r>
-          </a:p>
-          <a:p>
-            <a:pPr>
-              <a:defRPr sz="950">
+              <a:t>• الشركاء الفنيون والزراعيون: معهد بحوث الصرف (DRI) للمواصفات والتحقق المستقل، ووزارة الزراعة (MALR) لتحسين المحاصيل والإرشاد.</a:t>
+            </a:r>
+          </a:p>
+          <a:p>
+            <a:pPr algn="r">
+              <a:defRPr sz="900">
                 <a:solidFill>
                   <a:srgbClr val="F8FAFC"/>
                 </a:solidFill>
               </a:defRPr>
             </a:pPr>
             <a:r>
-              <a:t>• Energy &amp; Regulatory Partner: New &amp; Renewable Energy Authority (NREA) &amp; EgyptERA for 50 MW net-metering grid interconnection.</a:t>
-            </a:r>
-          </a:p>
-          <a:p>
-            <a:pPr>
-              <a:defRPr sz="950">
+              <a:t>• شريك الطاقة والربط الشبكي: هيئة الطاقة المتجددة (NREA) وجهاز تنظيم الكهرباء (EgyptERA) لتطبيق صافي القياس (Net Metering).</a:t>
+            </a:r>
+          </a:p>
+          <a:p>
+            <a:pPr algn="r">
+              <a:defRPr sz="900">
                 <a:solidFill>
                   <a:srgbClr val="F8FAFC"/>
                 </a:solidFill>
               </a:defRPr>
             </a:pPr>
             <a:r>
-              <a:t>• Agricultural Extension: Ministry of Agriculture &amp; Land Reclamation (MALR) for crop yield monitoring &amp; farmer advisory.</a:t>
-            </a:r>
-          </a:p>
-          <a:p>
-            <a:pPr>
-              <a:defRPr sz="950">
+              <a:t>• الحوكمة المجتمعية والميدانية: روابط مستخدمي المياه (WUAs) للمشاركة في إدارة المياه عبر تطبيق المحمول (Smart Farmer Drainage).</a:t>
+            </a:r>
+          </a:p>
+          <a:p>
+            <a:pPr algn="r">
+              <a:defRPr sz="900">
                 <a:solidFill>
                   <a:srgbClr val="F8FAFC"/>
                 </a:solidFill>
               </a:defRPr>
             </a:pPr>
             <a:r>
-              <a:t>• Local Governance &amp; Ownership: Farmers' Water User Associations (WUAs) co-managing water tables via the 'Smart Farmer' mobile app.</a:t>
-            </a:r>
-          </a:p>
-          <a:p>
-            <a:pPr>
-              <a:defRPr sz="950">
+              <a:t>• هيكل الحوكمة متعدد المستويات: • لجنة وزارية توجيهية عليا (الري، الزراعة، البيئة، المالية).</a:t>
+            </a:r>
+            <a:br/>
+            <a:r>
+              <a:t>• وحدة مخصصة لإدارة المشروع (PIU) داخل هيئة الصرف.</a:t>
+            </a:r>
+            <a:br/>
+            <a:r>
+              <a:t>• لجان محلية بالمحافظات لروابط المزارعين في كفر الشيخ والدقهلية.</a:t>
+            </a:r>
+          </a:p>
+          <a:p>
+            <a:pPr algn="r">
+              <a:defRPr sz="900">
                 <a:solidFill>
                   <a:srgbClr val="F8FAFC"/>
                 </a:solidFill>
               </a:defRPr>
             </a:pPr>
             <a:r>
-              <a:t>• Multi-Tier Governance Structure: • Steering Committee: Inter-ministerial oversight (MWRI, MALR, MoE, MoF).</a:t>
-            </a:r>
-            <a:br/>
-            <a:r>
-              <a:t>• Dedicated PIU: Project Implementation Unit inside EPADP.</a:t>
-            </a:r>
-            <a:br/>
-            <a:r>
-              <a:t>• Multi-Stakeholder Platform: Local WUA committees in Kafr El-Sheikh &amp; Dakahlia.</a:t>
-            </a:r>
-          </a:p>
-          <a:p>
-            <a:pPr>
-              <a:defRPr sz="950">
-                <a:solidFill>
-                  <a:srgbClr val="F8FAFC"/>
-                </a:solidFill>
-              </a:defRPr>
-            </a:pPr>
-            <a:r>
-              <a:t>• Strategic Alignment: Fully aligned with MWRI Water &amp; Irrigation System 2.0 (Presidential Initiative), Egypt Vision 2030, and National Climate Change Strategy 2050.</a:t>
+              <a:t>• التوافق الاستراتيجي الوطني: متوافق تماماً مع مبادرة 'منظومة المياه والري 2.0'، ورؤية مصر 2030، واستراتيجية تغير المناخ 2050.</a:t>
             </a:r>
           </a:p>
         </p:txBody>
@@ -3735,7 +3723,7 @@
         <p:spPr>
           <a:xfrm>
             <a:off x="731520" y="365760"/>
-            <a:ext cx="10728655" cy="1005840"/>
+            <a:ext cx="10728655" cy="1051560"/>
           </a:xfrm>
           <a:prstGeom prst="rect">
             <a:avLst/>
@@ -3748,7 +3736,7 @@
           </a:bodyPr>
           <a:lstStyle/>
           <a:p>
-            <a:pPr>
+            <a:pPr algn="r">
               <a:defRPr sz="950" b="1">
                 <a:solidFill>
                   <a:srgbClr val="15B5A4"/>
@@ -3756,23 +3744,23 @@
               </a:defRPr>
             </a:pPr>
             <a:r>
-              <a:t>SLIDE 2 OF 3 | 5-MIN EXECUTIVE PITCH | WEFE NEXUS PROFESSIONAL SERIES</a:t>
-            </a:r>
-          </a:p>
-          <a:p>
-            <a:pPr>
-              <a:defRPr sz="2000" b="1">
+              <a:t>الشريحة 2 من 3 | عرض تنفيذي في 5 دقائق | برنامج تمويل المرونة ومحور WEFE</a:t>
+            </a:r>
+          </a:p>
+          <a:p>
+            <a:pPr algn="r">
+              <a:defRPr sz="1900" b="1">
                 <a:solidFill>
                   <a:srgbClr val="F8FAFC"/>
                 </a:solidFill>
               </a:defRPr>
             </a:pPr>
             <a:r>
-              <a:t>Integrated WEFE Interventions, Nexus Value &amp; Resilience Scorecard</a:t>
-            </a:r>
-          </a:p>
-          <a:p>
-            <a:pPr>
+              <a:t>تدخلات WEFE المتكاملة، مصفوفة الفرز الرسمية، وتعزيز الجدوى البنكية</a:t>
+            </a:r>
+          </a:p>
+          <a:p>
+            <a:pPr algn="r">
               <a:defRPr sz="1100">
                 <a:solidFill>
                   <a:srgbClr val="F0C860"/>
@@ -3780,7 +3768,7 @@
               </a:defRPr>
             </a:pPr>
             <a:r>
-              <a:t>2. Main WEFE Interventions &amp; Closed-Loop Benefits | Feedback Report Corrections: Screening Matrix, Ecosystem &amp; Bankability</a:t>
+              <a:t>2. التدخلات الرئيسية ومنافع WEFE المغلقة | تصحيحات التقرير: مصفوفة الفرز، النظم البيئية وتعزيز التمويل</a:t>
             </a:r>
           </a:p>
         </p:txBody>
@@ -3852,7 +3840,7 @@
           </a:bodyPr>
           <a:lstStyle/>
           <a:p>
-            <a:pPr>
+            <a:pPr algn="r">
               <a:defRPr sz="1200" b="1">
                 <a:solidFill>
                   <a:srgbClr val="F0C860"/>
@@ -3860,7 +3848,7 @@
               </a:defRPr>
             </a:pPr>
             <a:r>
-              <a:t>⚡ 1. The 4 Closed-Loop WEFE Interventions (100,000 Feddans Pilot)</a:t>
+              <a:t>⚡ 1. التدخلات الأربعة المغلقة لمحور WEFE (المشروع التجريبي 100,000 فدان)</a:t>
             </a:r>
           </a:p>
         </p:txBody>
@@ -3887,7 +3875,7 @@
           </a:bodyPr>
           <a:lstStyle/>
           <a:p>
-            <a:pPr>
+            <a:pPr algn="r">
               <a:defRPr sz="950">
                 <a:solidFill>
                   <a:srgbClr val="F8FAFC"/>
@@ -3895,11 +3883,11 @@
               </a:defRPr>
             </a:pPr>
             <a:r>
-              <a:t>💧 WATER (الـمـيـاه): Retrofit 100k feddans with HDPE &amp; geotextile filters (40+ yr life). Motorized gate valves control water table, leveraging Capillary Rise (h=2γcosθ/ρgr) to save 150M m³/yr (25–30% irrigation water).</a:t>
-            </a:r>
-          </a:p>
-          <a:p>
-            <a:pPr>
+              <a:t>💧 المياه (Water): إحلال 100 ألف فدان بمواسير HDPE وفلاتر جيوتكستيل (40+ سنة عمر). صمامات كهربائية تتحكم بالصعود الشعري (h=2γcosθ/ρgr) لتوفير 150M م³/سنة مياه ري (25-30%).</a:t>
+            </a:r>
+          </a:p>
+          <a:p>
+            <a:pPr algn="r">
               <a:defRPr sz="950">
                 <a:solidFill>
                   <a:srgbClr val="F8FAFC"/>
@@ -3907,11 +3895,11 @@
               </a:defRPr>
             </a:pPr>
             <a:r>
-              <a:t>☀️ ENERGY (الـطـاقـة): 50 MW distributed solar PV across 25 pump stations producing 90 GWh/yr. Offsets 40% pumping electricity bill; surplus exported via EgyptERA Net Metering to national grid.</a:t>
-            </a:r>
-          </a:p>
-          <a:p>
-            <a:pPr>
+              <a:t>☀️ الطاقة (Energy): محطات شمسية 50 MW موزعة على 25 محطة رفع تولد 90 GWh/سنة وتخفض فاتورة الكهرباء 40% مع تصدير الفائض للشبكة القومية بنظام صافي القياس.</a:t>
+            </a:r>
+          </a:p>
+          <a:p>
+            <a:pPr algn="r">
               <a:defRPr sz="950">
                 <a:solidFill>
                   <a:srgbClr val="F8FAFC"/>
@@ -3919,11 +3907,11 @@
               </a:defRPr>
             </a:pPr>
             <a:r>
-              <a:t>🌾 FOOD (الـغـذاء): Yield restored by 15–25% (wheat, rice, maize) across 100,000 feddans. Soil EC probe automated flushing (opens valve when EC &gt; 4 dS/m; closes when EC &lt; 2 dS/m).</a:t>
-            </a:r>
-          </a:p>
-          <a:p>
-            <a:pPr>
+              <a:t>🌾 الغذاء (Food): زيادة إنتاجية القمح والأرز والذرة 15-25%، مع غسيل أملاح ذكي تلقائي يفتح الصمام عند EC &gt; 4 dS/m ويغلقه عند EC &lt; 2 dS/m.</a:t>
+            </a:r>
+          </a:p>
+          <a:p>
+            <a:pPr algn="r">
               <a:defRPr sz="950">
                 <a:solidFill>
                   <a:srgbClr val="F8FAFC"/>
@@ -3931,7 +3919,7 @@
               </a:defRPr>
             </a:pPr>
             <a:r>
-              <a:t>🌿 ECOSYSTEMS (الـبـيـئـة): 20 constructed wetlands (4,760 feddans) treating 200M m³/yr of drainage water biologically (Phragmites/Typha). Protects Delta lakes fisheries + 100k tCO₂/yr (Verra VM0033).</a:t>
+              <a:t>🌿 النظم البيئية (Ecosystems): 20 محطة أراضٍ رطبة اصطناعية (4,760 فدان) تعالج 200M م³/سنة حيوياً وتحمي بحيرات الدلتا الشمالية، وتحتجز 100k طن CO₂ (شهادات Verra VM0033).</a:t>
             </a:r>
           </a:p>
         </p:txBody>
@@ -3944,8 +3932,8 @@
         </p:nvSpPr>
         <p:spPr>
           <a:xfrm>
-            <a:off x="731520" y="4069080"/>
-            <a:ext cx="5212080" cy="2331720"/>
+            <a:off x="6217920" y="4069080"/>
+            <a:ext cx="5242255" cy="2331720"/>
           </a:xfrm>
           <a:prstGeom prst="roundRect">
             <a:avLst/>
@@ -3989,8 +3977,8 @@
         </p:nvSpPr>
         <p:spPr>
           <a:xfrm>
-            <a:off x="914400" y="4206240"/>
-            <a:ext cx="4846320" cy="365760"/>
+            <a:off x="6400800" y="4206240"/>
+            <a:ext cx="4876495" cy="365760"/>
           </a:xfrm>
           <a:prstGeom prst="rect">
             <a:avLst/>
@@ -4003,7 +3991,7 @@
           </a:bodyPr>
           <a:lstStyle/>
           <a:p>
-            <a:pPr>
+            <a:pPr algn="r">
               <a:defRPr sz="1200" b="1">
                 <a:solidFill>
                   <a:srgbClr val="15B5A4"/>
@@ -4011,7 +3999,7 @@
               </a:defRPr>
             </a:pPr>
             <a:r>
-              <a:t>📊 2. Formal WEFE Screening Matrix &amp; Resilience Scoring</a:t>
+              <a:t>📊 2. مصفوفة فرز WEFE الرسمية وبطاقة قياس المرونة</a:t>
             </a:r>
           </a:p>
         </p:txBody>
@@ -4024,8 +4012,8 @@
         </p:nvSpPr>
         <p:spPr>
           <a:xfrm>
-            <a:off x="914400" y="4572000"/>
-            <a:ext cx="4846320" cy="1737360"/>
+            <a:off x="6400800" y="4572000"/>
+            <a:ext cx="4876495" cy="1737360"/>
           </a:xfrm>
           <a:prstGeom prst="rect">
             <a:avLst/>
@@ -4038,7 +4026,7 @@
           </a:bodyPr>
           <a:lstStyle/>
           <a:p>
-            <a:pPr>
+            <a:pPr algn="r">
               <a:defRPr sz="850">
                 <a:solidFill>
                   <a:srgbClr val="F8FAFC"/>
@@ -4046,11 +4034,11 @@
               </a:defRPr>
             </a:pPr>
             <a:r>
-              <a:t>• Water Dimension (Score: 10/10): 150M m³/yr saved; water table stabilized at 0.8–1.2m.</a:t>
-            </a:r>
-          </a:p>
-          <a:p>
-            <a:pPr>
+              <a:t>• بعد المياه (الدرجة: 10/10): وفر 150M م³/سنة؛ تثبيت منسوب الماء الأرضي عند 0.8-1.2م.</a:t>
+            </a:r>
+          </a:p>
+          <a:p>
+            <a:pPr algn="r">
               <a:defRPr sz="850">
                 <a:solidFill>
                   <a:srgbClr val="F8FAFC"/>
@@ -4058,11 +4046,11 @@
               </a:defRPr>
             </a:pPr>
             <a:r>
-              <a:t>• Energy Dimension (Score: 8/10): 50 MW solar; 90 GWh/yr clean power; 40% OPEX cut.</a:t>
-            </a:r>
-          </a:p>
-          <a:p>
-            <a:pPr>
+              <a:t>• بعد الطاقة (الدرجة: 8/10): 50 MW شمسية؛ 90 GWh/سنة؛ خفض تكاليف الضخ 40%.</a:t>
+            </a:r>
+          </a:p>
+          <a:p>
+            <a:pPr algn="r">
               <a:defRPr sz="850">
                 <a:solidFill>
                   <a:srgbClr val="F8FAFC"/>
@@ -4070,11 +4058,11 @@
               </a:defRPr>
             </a:pPr>
             <a:r>
-              <a:t>• Food Dimension (Score: 10/10): 15–25% yield boost; import substitution; 200k farmers.</a:t>
-            </a:r>
-          </a:p>
-          <a:p>
-            <a:pPr>
+              <a:t>• بعد الغذاء (الدرجة: 10/10): زيادة المحاصيل 15-25%؛ دعم أمن الغذاء لـ 200,000 مزارع.</a:t>
+            </a:r>
+          </a:p>
+          <a:p>
+            <a:pPr algn="r">
               <a:defRPr sz="850">
                 <a:solidFill>
                   <a:srgbClr val="F8FAFC"/>
@@ -4082,11 +4070,11 @@
               </a:defRPr>
             </a:pPr>
             <a:r>
-              <a:t>• Ecosystem Dimension (Score: 8/10): 4,760 feddans wetlands; blue carbon; lake biodiversity.</a:t>
-            </a:r>
-          </a:p>
-          <a:p>
-            <a:pPr>
+              <a:t>• بعد النظم البيئية (الدرجة: 8/10): 4,760 فدان رطبة؛ كربون أزرق؛ حماية الثروة السمكية.</a:t>
+            </a:r>
+          </a:p>
+          <a:p>
+            <a:pPr algn="r">
               <a:defRPr sz="850">
                 <a:solidFill>
                   <a:srgbClr val="F8FAFC"/>
@@ -4094,11 +4082,11 @@
               </a:defRPr>
             </a:pPr>
             <a:r>
-              <a:t>• Enabler Dimension (Score: 9/10): 5,000 IoT nodes (ESP32); AI digital twin; tamper alert.</a:t>
-            </a:r>
-          </a:p>
-          <a:p>
-            <a:pPr>
+              <a:t>• الممكنات الرقمية (الدرجة: 9/10): 5,000 عقدة IoT؛ توأم رقمي؛ رصد تلاعب لحظي مشفر.</a:t>
+            </a:r>
+          </a:p>
+          <a:p>
+            <a:pPr algn="r">
               <a:defRPr sz="850">
                 <a:solidFill>
                   <a:srgbClr val="F0C860"/>
@@ -4106,7 +4094,7 @@
               </a:defRPr>
             </a:pPr>
             <a:r>
-              <a:t>• COMPOSITE WEFE SCORE: 92/100: RESILIENCE SCORECARD: HIGH across all 5 dimensions.</a:t>
+              <a:t>• التقييم المركب لمشروع WEFE: 92 / 100 | بطاقة قياس المرونة: HIGH عبر الأبعاد الـ 5.</a:t>
             </a:r>
           </a:p>
         </p:txBody>
@@ -4119,8 +4107,8 @@
         </p:nvSpPr>
         <p:spPr>
           <a:xfrm>
-            <a:off x="6217920" y="4069080"/>
-            <a:ext cx="5242255" cy="2331720"/>
+            <a:off x="731520" y="4069080"/>
+            <a:ext cx="5212080" cy="2331720"/>
           </a:xfrm>
           <a:prstGeom prst="roundRect">
             <a:avLst/>
@@ -4164,8 +4152,8 @@
         </p:nvSpPr>
         <p:spPr>
           <a:xfrm>
-            <a:off x="6400800" y="4206240"/>
-            <a:ext cx="4876495" cy="365760"/>
+            <a:off x="914400" y="4206240"/>
+            <a:ext cx="4846320" cy="365760"/>
           </a:xfrm>
           <a:prstGeom prst="rect">
             <a:avLst/>
@@ -4178,7 +4166,7 @@
           </a:bodyPr>
           <a:lstStyle/>
           <a:p>
-            <a:pPr>
+            <a:pPr algn="r">
               <a:defRPr sz="1200" b="1">
                 <a:solidFill>
                   <a:srgbClr val="10B981"/>
@@ -4186,7 +4174,7 @@
               </a:defRPr>
             </a:pPr>
             <a:r>
-              <a:t>💎 3. How WEFE Integration Directly Drives Bankability</a:t>
+              <a:t>💎 3. كيف يعزز تكامل WEFE الجدوى البنكية للمشروع</a:t>
             </a:r>
           </a:p>
         </p:txBody>
@@ -4199,8 +4187,8 @@
         </p:nvSpPr>
         <p:spPr>
           <a:xfrm>
-            <a:off x="6400800" y="4572000"/>
-            <a:ext cx="4876495" cy="1737360"/>
+            <a:off x="914400" y="4572000"/>
+            <a:ext cx="4846320" cy="1737360"/>
           </a:xfrm>
           <a:prstGeom prst="rect">
             <a:avLst/>
@@ -4213,7 +4201,7 @@
           </a:bodyPr>
           <a:lstStyle/>
           <a:p>
-            <a:pPr>
+            <a:pPr algn="r">
               <a:defRPr sz="850">
                 <a:solidFill>
                   <a:srgbClr val="F8FAFC"/>
@@ -4221,11 +4209,11 @@
               </a:defRPr>
             </a:pPr>
             <a:r>
-              <a:t>• OPEX Self-Sufficiency: Solar generation monetized via Net Metering pays pump electricity, slashing default risk and protecting DSCR (1.35x).</a:t>
-            </a:r>
-          </a:p>
-          <a:p>
-            <a:pPr>
+              <a:t>• الاكتفاء الذاتي من تكاليف التشغيل: الطاقة الشمسية المصدرة تسدد فواتير كهرباء الطلمبات، مما يحمي نسبة خدمة الدين (DSCR = 1.35x).</a:t>
+            </a:r>
+          </a:p>
+          <a:p>
+            <a:pPr algn="r">
               <a:defRPr sz="850">
                 <a:solidFill>
                   <a:srgbClr val="F8FAFC"/>
@@ -4233,11 +4221,11 @@
               </a:defRPr>
             </a:pPr>
             <a:r>
-              <a:t>• Quantified Avoided-Cost Value: Saving 150M m³/yr is valued at $52.5M/yr (at $0.35/m³ alternative supply), yielding an investment payback of only 0.48 years for smart irrigation.</a:t>
-            </a:r>
-          </a:p>
-          <a:p>
-            <a:pPr>
+              <a:t>• قيمة التكلفة المتجنبة (Avoided Costs): توفير 150M م³ مياه يعادل 52.5M دولار/سنة بتكلفة البديل (0.35$/م³)، محققاً فترة استرداد 0.48 سنة للري الذكي.</a:t>
+            </a:r>
+          </a:p>
+          <a:p>
+            <a:pPr algn="r">
               <a:defRPr sz="850">
                 <a:solidFill>
                   <a:srgbClr val="F8FAFC"/>
@@ -4245,11 +4233,11 @@
               </a:defRPr>
             </a:pPr>
             <a:r>
-              <a:t>• Diversified Revenue Streams: Energy savings ($8M/yr) + Grid export ($3M/yr) + Avoided water costs ($5M/yr) + Carbon offsets ($0.5M/yr) + Enhanced farmer tariffs.</a:t>
-            </a:r>
-          </a:p>
-          <a:p>
-            <a:pPr>
+              <a:t>• تنوع التدفقات النقدية الإيرادية: وفر طاقة ($8M) + تصدير شبكة ($3M) + مياه متجنبة ($5M) + أرصدة كربون ($0.5M) ورسوم صيانة.</a:t>
+            </a:r>
+          </a:p>
+          <a:p>
+            <a:pPr algn="r">
               <a:defRPr sz="850">
                 <a:solidFill>
                   <a:srgbClr val="F8FAFC"/>
@@ -4257,7 +4245,7 @@
               </a:defRPr>
             </a:pPr>
             <a:r>
-              <a:t>• Zero Downstream Displacement: Unlike mega-diversion plants (Bahr El-Baqar), Eco-Drain operates in-situ, eliminating community conflict and environmental safeguard rejection.</a:t>
+              <a:t>• انعدام النزاعات الاجتماعية: تطوير موضعي (In-situ) في أراضي الدلتا القديمة دون تحويل المياه بعيداً عن صغار المزارعين (بخلاف مشاريع بحر البقر والمحسمة).</a:t>
             </a:r>
           </a:p>
         </p:txBody>
@@ -4332,7 +4320,7 @@
         <p:spPr>
           <a:xfrm>
             <a:off x="731520" y="365760"/>
-            <a:ext cx="10728655" cy="1005840"/>
+            <a:ext cx="10728655" cy="1051560"/>
           </a:xfrm>
           <a:prstGeom prst="rect">
             <a:avLst/>
@@ -4345,7 +4333,7 @@
           </a:bodyPr>
           <a:lstStyle/>
           <a:p>
-            <a:pPr>
+            <a:pPr algn="r">
               <a:defRPr sz="950" b="1">
                 <a:solidFill>
                   <a:srgbClr val="15B5A4"/>
@@ -4353,23 +4341,23 @@
               </a:defRPr>
             </a:pPr>
             <a:r>
-              <a:t>SLIDE 3 OF 3 | 5-MIN EXECUTIVE PITCH | WEFE NEXUS PROFESSIONAL SERIES</a:t>
-            </a:r>
-          </a:p>
-          <a:p>
-            <a:pPr>
-              <a:defRPr sz="2000" b="1">
+              <a:t>الشريحة 3 من 3 | عرض تنفيذي في 5 دقائق | برنامج تمويل المرونة ومحور WEFE</a:t>
+            </a:r>
+          </a:p>
+          <a:p>
+            <a:pPr algn="r">
+              <a:defRPr sz="1900" b="1">
                 <a:solidFill>
                   <a:srgbClr val="F8FAFC"/>
                 </a:solidFill>
               </a:defRPr>
             </a:pPr>
             <a:r>
-              <a:t>Blended Finance Capital Stack, Readiness, KPIs &amp; Scaling Strategy</a:t>
-            </a:r>
-          </a:p>
-          <a:p>
-            <a:pPr>
+              <a:t>هيكل رأس المال المختلط، الجاهزية، ومسار التوسع الإقليمي</a:t>
+            </a:r>
+          </a:p>
+          <a:p>
+            <a:pPr algn="r">
               <a:defRPr sz="1100">
                 <a:solidFill>
                   <a:srgbClr val="F0C860"/>
@@ -4377,7 +4365,7 @@
               </a:defRPr>
             </a:pPr>
             <a:r>
-              <a:t>4. Budget &amp; Financiers | 5. Readiness Status | 6. Expected Results &amp; Scaling Pathway</a:t>
+              <a:t>4. الميزانية والجهات الممولة | 5. الجاهزية والحقل التجريبي | 6. مؤشرات الأداء والتوسع الإقليمي</a:t>
             </a:r>
           </a:p>
         </p:txBody>
@@ -4390,8 +4378,8 @@
         </p:nvSpPr>
         <p:spPr>
           <a:xfrm>
-            <a:off x="731520" y="1463040"/>
-            <a:ext cx="5212080" cy="2560320"/>
+            <a:off x="6217920" y="1463040"/>
+            <a:ext cx="5242255" cy="2560320"/>
           </a:xfrm>
           <a:prstGeom prst="roundRect">
             <a:avLst/>
@@ -4435,8 +4423,8 @@
         </p:nvSpPr>
         <p:spPr>
           <a:xfrm>
-            <a:off x="914400" y="1600200"/>
-            <a:ext cx="4846320" cy="365760"/>
+            <a:off x="6400800" y="1600200"/>
+            <a:ext cx="4876495" cy="365760"/>
           </a:xfrm>
           <a:prstGeom prst="rect">
             <a:avLst/>
@@ -4449,7 +4437,7 @@
           </a:bodyPr>
           <a:lstStyle/>
           <a:p>
-            <a:pPr>
+            <a:pPr algn="r">
               <a:defRPr sz="1200" b="1">
                 <a:solidFill>
                   <a:srgbClr val="F0C860"/>
@@ -4457,7 +4445,7 @@
               </a:defRPr>
             </a:pPr>
             <a:r>
-              <a:t>💰 1. Total Investment ($420M) &amp; Blended Capital Stack</a:t>
+              <a:t>💰 1. إجمالي التكلفة (420M$) وهيكل رأس المال المختلط</a:t>
             </a:r>
           </a:p>
         </p:txBody>
@@ -4470,8 +4458,8 @@
         </p:nvSpPr>
         <p:spPr>
           <a:xfrm>
-            <a:off x="914400" y="1965960"/>
-            <a:ext cx="4846320" cy="1965960"/>
+            <a:off x="6400800" y="1965960"/>
+            <a:ext cx="4876495" cy="1965960"/>
           </a:xfrm>
           <a:prstGeom prst="rect">
             <a:avLst/>
@@ -4484,7 +4472,7 @@
           </a:bodyPr>
           <a:lstStyle/>
           <a:p>
-            <a:pPr>
+            <a:pPr algn="r">
               <a:defRPr sz="880">
                 <a:solidFill>
                   <a:srgbClr val="F8FAFC"/>
@@ -4492,11 +4480,11 @@
               </a:defRPr>
             </a:pPr>
             <a:r>
-              <a:t>• Total CAPEX: USD 420 Million ($4,200/feddan all-inclusive vs. $1,800/feddan baseline drainage).</a:t>
-            </a:r>
-          </a:p>
-          <a:p>
-            <a:pPr>
+              <a:t>• إجمالي الاستثمار: 420 مليون دولار (4,200 دولار/فدان لكافة العناصر الهندسية والتقنية والبيئية).</a:t>
+            </a:r>
+          </a:p>
+          <a:p>
+            <a:pPr algn="r">
               <a:defRPr sz="880">
                 <a:solidFill>
                   <a:srgbClr val="F8FAFC"/>
@@ -4504,11 +4492,11 @@
               </a:defRPr>
             </a:pPr>
             <a:r>
-              <a:t>• 15% Grants / TA ($63M): GCF Readiness, AfDB, GEF for Feasibility, 10-feddan pilot, Digital Twin.</a:t>
-            </a:r>
-          </a:p>
-          <a:p>
-            <a:pPr>
+              <a:t>• 15% منح ومساعدات فنية (63M$): من GCF و AfDB و EU للحقل التجريبي والمنصة ودراسات الجدوى.</a:t>
+            </a:r>
+          </a:p>
+          <a:p>
+            <a:pPr algn="r">
               <a:defRPr sz="880">
                 <a:solidFill>
                   <a:srgbClr val="F8FAFC"/>
@@ -4516,11 +4504,11 @@
               </a:defRPr>
             </a:pPr>
             <a:r>
-              <a:t>• 20% Government Equity ($84M): In-kind land for wetlands, existing pump stations, EPADP engineering staff.</a:t>
-            </a:r>
-          </a:p>
-          <a:p>
-            <a:pPr>
+              <a:t>• 20% مساهمة حكومية عينية (84M$): أراضٍ ومحطات طلمبات قائمة وكوادر هيئة الصرف.</a:t>
+            </a:r>
+          </a:p>
+          <a:p>
+            <a:pPr algn="r">
               <a:defRPr sz="880">
                 <a:solidFill>
                   <a:srgbClr val="F8FAFC"/>
@@ -4528,11 +4516,11 @@
               </a:defRPr>
             </a:pPr>
             <a:r>
-              <a:t>• 40% Concessional Debt ($168M): World Bank (NDP V), AfDB, IsDB (20–25 yr tenor, long grace period).</a:t>
-            </a:r>
-          </a:p>
-          <a:p>
-            <a:pPr>
+              <a:t>• 40% قروض ميسرة (168M$): البنك الدولي (NDP V)، وبنك التنمية الأفريقي (سداد 20-25 سنة).</a:t>
+            </a:r>
+          </a:p>
+          <a:p>
+            <a:pPr algn="r">
               <a:defRPr sz="880">
                 <a:solidFill>
                   <a:srgbClr val="F8FAFC"/>
@@ -4540,11 +4528,11 @@
               </a:defRPr>
             </a:pPr>
             <a:r>
-              <a:t>• 25% Commercial Debt / PPP ($105M): Private solar developers secured by solar PPA and energy savings.</a:t>
-            </a:r>
-          </a:p>
-          <a:p>
-            <a:pPr>
+              <a:t>• 25% قروض تجارية وشراكة PPP (105M$): لمكون الطاقة الشمسية 50 MW مدعوماً باتفاقيات PPA.</a:t>
+            </a:r>
+          </a:p>
+          <a:p>
+            <a:pPr algn="r">
               <a:defRPr sz="880">
                 <a:solidFill>
                   <a:srgbClr val="F8FAFC"/>
@@ -4552,7 +4540,7 @@
               </a:defRPr>
             </a:pPr>
             <a:r>
-              <a:t>• Financial Returns: Project EIRR: 21.4% | DSCR: 1.35x (stress tested) | Payback: 8 years.</a:t>
+              <a:t>• مؤشرات الربحية الاقتصادية: EIRR = 21.4% | DSCR = 1.35x (تحت الضغط) | استرداد 8 سنوات.</a:t>
             </a:r>
           </a:p>
         </p:txBody>
@@ -4565,8 +4553,8 @@
         </p:nvSpPr>
         <p:spPr>
           <a:xfrm>
-            <a:off x="731520" y="4160520"/>
-            <a:ext cx="5212080" cy="2240280"/>
+            <a:off x="6217920" y="4160520"/>
+            <a:ext cx="5242255" cy="2240280"/>
           </a:xfrm>
           <a:prstGeom prst="roundRect">
             <a:avLst/>
@@ -4610,8 +4598,8 @@
         </p:nvSpPr>
         <p:spPr>
           <a:xfrm>
-            <a:off x="914400" y="4297680"/>
-            <a:ext cx="4846320" cy="365760"/>
+            <a:off x="6400800" y="4297680"/>
+            <a:ext cx="4876495" cy="365760"/>
           </a:xfrm>
           <a:prstGeom prst="rect">
             <a:avLst/>
@@ -4624,7 +4612,7 @@
           </a:bodyPr>
           <a:lstStyle/>
           <a:p>
-            <a:pPr>
+            <a:pPr algn="r">
               <a:defRPr sz="1200" b="1">
                 <a:solidFill>
                   <a:srgbClr val="15B5A4"/>
@@ -4632,7 +4620,7 @@
               </a:defRPr>
             </a:pPr>
             <a:r>
-              <a:t>🎯 2. Funding Call Fit Score Assessment</a:t>
+              <a:t>🎯 2. تحليل ملاءمة جهات التمويل (Funding Call Fit)</a:t>
             </a:r>
           </a:p>
         </p:txBody>
@@ -4645,8 +4633,8 @@
         </p:nvSpPr>
         <p:spPr>
           <a:xfrm>
-            <a:off x="914400" y="4663440"/>
-            <a:ext cx="4846320" cy="1645920"/>
+            <a:off x="6400800" y="4663440"/>
+            <a:ext cx="4876495" cy="1645920"/>
           </a:xfrm>
           <a:prstGeom prst="rect">
             <a:avLst/>
@@ -4659,7 +4647,7 @@
           </a:bodyPr>
           <a:lstStyle/>
           <a:p>
-            <a:pPr>
+            <a:pPr algn="r">
               <a:defRPr sz="880">
                 <a:solidFill>
                   <a:srgbClr val="F8FAFC"/>
@@ -4667,11 +4655,11 @@
               </a:defRPr>
             </a:pPr>
             <a:r>
-              <a:t>• Green Climate Fund (GCF) Adaptation Window: 14/14 Score (Decision: GO) — Perfect match for transformational adaptation, mitigation co-benefits, and MRV automation.</a:t>
-            </a:r>
-          </a:p>
-          <a:p>
-            <a:pPr>
+              <a:t>• صندوق المناخ الأخضر (GCF Adaptation): درجة 14/14 (قرار: GO) - تطابق كامل مع نافذة التكيف والتخفيف والتحول الرقمي.</a:t>
+            </a:r>
+          </a:p>
+          <a:p>
+            <a:pPr algn="r">
               <a:defRPr sz="880">
                 <a:solidFill>
                   <a:srgbClr val="F8FAFC"/>
@@ -4679,11 +4667,11 @@
               </a:defRPr>
             </a:pPr>
             <a:r>
-              <a:t>• Adaptation Fund: 13/14 Score (Decision: GO for Component / 10-feddan Pilot Submission).</a:t>
-            </a:r>
-          </a:p>
-          <a:p>
-            <a:pPr>
+              <a:t>• صندوق التكيف (Adaptation Fund): درجة 13/14 (قرار: GO لمقترح مجزأ أو الحقل التجريبي 10 أفدنة).</a:t>
+            </a:r>
+          </a:p>
+          <a:p>
+            <a:pPr algn="r">
               <a:defRPr sz="880">
                 <a:solidFill>
                   <a:srgbClr val="F8FAFC"/>
@@ -4691,7 +4679,7 @@
               </a:defRPr>
             </a:pPr>
             <a:r>
-              <a:t>• PRIMA &amp; EU Global Gateway: High Fit for Euro-Mediterranean digital water management, circular agriculture, and climate resilience.</a:t>
+              <a:t>• برنامج PRIMA وبوابة الاتحاد الأوروبي: ملاءمة مرتفعة جداً للتحول الرقمي الزراعي والتعاون الأورومتوسطي.</a:t>
             </a:r>
           </a:p>
         </p:txBody>
@@ -4704,8 +4692,8 @@
         </p:nvSpPr>
         <p:spPr>
           <a:xfrm>
-            <a:off x="6217920" y="1463040"/>
-            <a:ext cx="5242255" cy="2240280"/>
+            <a:off x="731520" y="1463040"/>
+            <a:ext cx="5212080" cy="2240280"/>
           </a:xfrm>
           <a:prstGeom prst="roundRect">
             <a:avLst/>
@@ -4749,8 +4737,8 @@
         </p:nvSpPr>
         <p:spPr>
           <a:xfrm>
-            <a:off x="6400800" y="1600200"/>
-            <a:ext cx="4876495" cy="365760"/>
+            <a:off x="914400" y="1600200"/>
+            <a:ext cx="4846320" cy="365760"/>
           </a:xfrm>
           <a:prstGeom prst="rect">
             <a:avLst/>
@@ -4763,7 +4751,7 @@
           </a:bodyPr>
           <a:lstStyle/>
           <a:p>
-            <a:pPr>
+            <a:pPr algn="r">
               <a:defRPr sz="1200" b="1">
                 <a:solidFill>
                   <a:srgbClr val="10B981"/>
@@ -4771,7 +4759,7 @@
               </a:defRPr>
             </a:pPr>
             <a:r>
-              <a:t>🚀 3. Implementation Readiness &amp; 10-Feddan Pilot Unit</a:t>
+              <a:t>🚀 3. حالة الجاهزية ووحدة الاختبار (10 أفدنة)</a:t>
             </a:r>
           </a:p>
         </p:txBody>
@@ -4784,8 +4772,8 @@
         </p:nvSpPr>
         <p:spPr>
           <a:xfrm>
-            <a:off x="6400800" y="1965960"/>
-            <a:ext cx="4876495" cy="1645920"/>
+            <a:off x="914400" y="1965960"/>
+            <a:ext cx="4846320" cy="1645920"/>
           </a:xfrm>
           <a:prstGeom prst="rect">
             <a:avLst/>
@@ -4798,7 +4786,7 @@
           </a:bodyPr>
           <a:lstStyle/>
           <a:p>
-            <a:pPr>
+            <a:pPr algn="r">
               <a:defRPr sz="880">
                 <a:solidFill>
                   <a:srgbClr val="F8FAFC"/>
@@ -4806,11 +4794,11 @@
               </a:defRPr>
             </a:pPr>
             <a:r>
-              <a:t>• Institutional Maturity: Built on EPADP's 50-year delivery platform (6M feddans installed); eliminates construction and execution risks.</a:t>
-            </a:r>
-          </a:p>
-          <a:p>
-            <a:pPr>
+              <a:t>• النضج المؤسسي والتنفيذي: خبرة 50 عاماً لهيئة الصرف (EPADP) في شبكات 6 ملايين فدان تقضي على المخاطر التنفيذية.</a:t>
+            </a:r>
+          </a:p>
+          <a:p>
+            <a:pPr algn="r">
               <a:defRPr sz="880">
                 <a:solidFill>
                   <a:srgbClr val="F8FAFC"/>
@@ -4818,11 +4806,11 @@
               </a:defRPr>
             </a:pPr>
             <a:r>
-              <a:t>• 10-Feddan Pilot Validation Unit: Engineered for immediate launch on a single isolated collector network to test dynamic capillary rise and IoT valve loops before scaling.</a:t>
-            </a:r>
-          </a:p>
-          <a:p>
-            <a:pPr>
+              <a:t>• وحدة الاختبار الحقلية (10 أفدنة): تصميم جاهز للتنفيذ الفوري على مجمع صرف مستقل لاختبار الصعود الشعري قبل التعميم.</a:t>
+            </a:r>
+          </a:p>
+          <a:p>
+            <a:pPr algn="r">
               <a:defRPr sz="880">
                 <a:solidFill>
                   <a:srgbClr val="F8FAFC"/>
@@ -4830,11 +4818,11 @@
               </a:defRPr>
             </a:pPr>
             <a:r>
-              <a:t>• Technology Readiness Level: High TRL (TRL 8-9) for HDPE pipes, solar PV, and LoRaWAN/NB-IoT ESP32 hardware.</a:t>
-            </a:r>
-          </a:p>
-          <a:p>
-            <a:pPr>
+              <a:t>• نضج التقنيات (TRL): مستوى TRL 8-9 لكافة مكونات HDPE والطاقة الشمسية وحساسات ESP32 و NB-IoT.</a:t>
+            </a:r>
+          </a:p>
+          <a:p>
+            <a:pPr algn="r">
               <a:defRPr sz="880">
                 <a:solidFill>
                   <a:srgbClr val="F8FAFC"/>
@@ -4842,7 +4830,7 @@
               </a:defRPr>
             </a:pPr>
             <a:r>
-              <a:t>• Immediate Next Step: Request Project Preparation Facility (PPF) Grant ($1.5M) from GCF/AfDB for site-specific feasibility in Kafr El-Sheikh.</a:t>
+              <a:t>• الخطوة التنفيذية الفورية: طلب منحة تحضيرية (PPF Grant بقيمة 1.5 مليون دولار) من GCF/AfDB لدراسات كفر الشيخ.</a:t>
             </a:r>
           </a:p>
         </p:txBody>
@@ -4855,8 +4843,8 @@
         </p:nvSpPr>
         <p:spPr>
           <a:xfrm>
-            <a:off x="6217920" y="3840480"/>
-            <a:ext cx="5242255" cy="2560320"/>
+            <a:off x="731520" y="3840480"/>
+            <a:ext cx="5212080" cy="2560320"/>
           </a:xfrm>
           <a:prstGeom prst="roundRect">
             <a:avLst/>
@@ -4900,8 +4888,8 @@
         </p:nvSpPr>
         <p:spPr>
           <a:xfrm>
-            <a:off x="6400800" y="3977640"/>
-            <a:ext cx="4876495" cy="365760"/>
+            <a:off x="914400" y="3977640"/>
+            <a:ext cx="4846320" cy="365760"/>
           </a:xfrm>
           <a:prstGeom prst="rect">
             <a:avLst/>
@@ -4914,7 +4902,7 @@
           </a:bodyPr>
           <a:lstStyle/>
           <a:p>
-            <a:pPr>
+            <a:pPr algn="r">
               <a:defRPr sz="1200" b="1">
                 <a:solidFill>
                   <a:srgbClr val="F8FAFC"/>
@@ -4922,7 +4910,7 @@
               </a:defRPr>
             </a:pPr>
             <a:r>
-              <a:t>📈 4. Main Expected Results &amp; Regional Scaling Pathway</a:t>
+              <a:t>📈 4. مؤشرات الأداء الرئيسية ومسار التوسع الإقليمي</a:t>
             </a:r>
           </a:p>
         </p:txBody>
@@ -4935,8 +4923,8 @@
         </p:nvSpPr>
         <p:spPr>
           <a:xfrm>
-            <a:off x="6400800" y="4343400"/>
-            <a:ext cx="4876495" cy="1965960"/>
+            <a:off x="914400" y="4343400"/>
+            <a:ext cx="4846320" cy="1965960"/>
           </a:xfrm>
           <a:prstGeom prst="rect">
             <a:avLst/>
@@ -4949,7 +4937,7 @@
           </a:bodyPr>
           <a:lstStyle/>
           <a:p>
-            <a:pPr>
+            <a:pPr algn="r">
               <a:defRPr sz="850">
                 <a:solidFill>
                   <a:srgbClr val="F0C860"/>
@@ -4957,11 +4945,11 @@
               </a:defRPr>
             </a:pPr>
             <a:r>
-              <a:t>Core Quantified KPIs (Target: 100,000 Feddans): </a:t>
-            </a:r>
-          </a:p>
-          <a:p>
-            <a:pPr>
+              <a:t>مؤشرات الأداء الكمية المستهدفة (100,000 فدان): </a:t>
+            </a:r>
+          </a:p>
+          <a:p>
+            <a:pPr algn="r">
               <a:defRPr sz="850">
                 <a:solidFill>
                   <a:srgbClr val="F8FAFC"/>
@@ -4969,11 +4957,11 @@
               </a:defRPr>
             </a:pPr>
             <a:r>
-              <a:t>• 150 Million m³/yr water saved (smart controlled capillary drainage).</a:t>
-            </a:r>
-          </a:p>
-          <a:p>
-            <a:pPr>
+              <a:t>• 150 مليون م³/سنة وفر مائي عبر الصرف المحكوم والصعود الشعري.</a:t>
+            </a:r>
+          </a:p>
+          <a:p>
+            <a:pPr algn="r">
               <a:defRPr sz="850">
                 <a:solidFill>
                   <a:srgbClr val="F8FAFC"/>
@@ -4981,11 +4969,11 @@
               </a:defRPr>
             </a:pPr>
             <a:r>
-              <a:t>• 15–25% crop yield boost across 200,000+ direct beneficiary farmers.</a:t>
-            </a:r>
-          </a:p>
-          <a:p>
-            <a:pPr>
+              <a:t>• 15-25% زيادة إنتاجية المحاصيل لأكثر من 200,000 مزارع مستفيد.</a:t>
+            </a:r>
+          </a:p>
+          <a:p>
+            <a:pPr algn="r">
               <a:defRPr sz="850">
                 <a:solidFill>
                   <a:srgbClr val="F8FAFC"/>
@@ -4993,11 +4981,11 @@
               </a:defRPr>
             </a:pPr>
             <a:r>
-              <a:t>• 50 MW solar installed &amp; 90 GWh/yr clean energy produced.</a:t>
-            </a:r>
-          </a:p>
-          <a:p>
-            <a:pPr>
+              <a:t>• 50 MW طاقة شمسية و 90 GWh/سنة كهرباء نظيفة + خفض 40% من تكلفة الضخ.</a:t>
+            </a:r>
+          </a:p>
+          <a:p>
+            <a:pPr algn="r">
               <a:defRPr sz="850">
                 <a:solidFill>
                   <a:srgbClr val="F8FAFC"/>
@@ -5005,11 +4993,11 @@
               </a:defRPr>
             </a:pPr>
             <a:r>
-              <a:t>• 80% reduction in tampering incidents + failure detection from weeks to 1 hour.</a:t>
-            </a:r>
-          </a:p>
-          <a:p>
-            <a:pPr>
+              <a:t>• خفض التعديات 80% وكشف الأعطال في ساعة واحدة بدلاً من أسابيع.</a:t>
+            </a:r>
+          </a:p>
+          <a:p>
+            <a:pPr algn="r">
               <a:defRPr sz="850">
                 <a:solidFill>
                   <a:srgbClr val="F8FAFC"/>
@@ -5017,11 +5005,11 @@
               </a:defRPr>
             </a:pPr>
             <a:r>
-              <a:t>• 100,000 tCO₂e/yr emissions reduced via solar energy and restored wetlands.</a:t>
-            </a:r>
-          </a:p>
-          <a:p>
-            <a:pPr>
+              <a:t>• خفض 100,000 طن CO₂/سنة وتوفير 5,000 فرصة عمل مباشرة.</a:t>
+            </a:r>
+          </a:p>
+          <a:p>
+            <a:pPr algn="r">
               <a:defRPr sz="850">
                 <a:solidFill>
                   <a:srgbClr val="F0C860"/>
@@ -5029,7 +5017,7 @@
               </a:defRPr>
             </a:pPr>
             <a:r>
-              <a:t>Replication &amp; Scaling Strategy: Phase 1: 10-feddan pilot (Yr 1) -&gt; Phase 2: 100k feddans core pilot (Yrs 2-5) -&gt; Phase 3: Scaling across 4.3M feddans of Delta drainage and exporting model to Iraq, Jordan, and Pakistan.</a:t>
+              <a:t>مسار التوسع (3 مراحل): حقل تجريبي 10 أفدنة (سنة 1) -&gt; تجربة ريادية 100 ألف فدان (سنوات 2-5) -&gt; تعميم عبر 4.3M فدان بالدلتا ونقل التجربة إقليمياً للعراق والأردن وباكستان.</a:t>
             </a:r>
           </a:p>
         </p:txBody>

</xml_diff>